<commit_message>
marketing-studio: Canva 이관 시 요소 opacity 를 색에 합성
페이지 번호·카드 라벨/설명 등 opacity 가 걸린 텍스트가 100% 흰색으로
들어오던 문제 수정. 조상 opacity 곱을 배경과 미리 합성한 단색으로 넣는다.

Co-Authored-By: Claude Opus 5.5 <noreply@anthropic.com>
Claude-Session: https://claude.ai/code/session_016jNE99rPd9by56Ho7H9dLa
</commit_message>
<xml_diff>
--- a/service/marketing-studio/samples/tips-v1/canva/TIPS_캐러셀_5p.pptx
+++ b/service/marketing-studio/samples/tips-v1/canva/TIPS_캐러셀_5p.pptx
@@ -3215,7 +3215,7 @@
             <a:r>
               <a:rPr sz="1800" b="0" spc="-18">
                 <a:solidFill>
-                  <a:srgbClr val="FFFFFF"/>
+                  <a:srgbClr val="969CA8"/>
                 </a:solidFill>
                 <a:latin typeface="Noto Sans KR"/>
                 <a:ea typeface="Noto Sans KR"/>
@@ -3799,7 +3799,7 @@
             <a:r>
               <a:rPr sz="1800" b="0" spc="-18">
                 <a:solidFill>
-                  <a:srgbClr val="0F1A2E"/>
+                  <a:srgbClr val="767D89"/>
                 </a:solidFill>
                 <a:latin typeface="Noto Sans KR"/>
                 <a:ea typeface="Noto Sans KR"/>
@@ -3961,7 +3961,7 @@
             <a:r>
               <a:rPr sz="1800" b="1">
                 <a:solidFill>
-                  <a:srgbClr val="FFFFFF"/>
+                  <a:srgbClr val="B9BDC5"/>
                 </a:solidFill>
                 <a:latin typeface="Noto Sans KR"/>
                 <a:ea typeface="Noto Sans KR"/>
@@ -4043,7 +4043,7 @@
             <a:r>
               <a:rPr sz="2025" b="0">
                 <a:solidFill>
-                  <a:srgbClr val="FFFFFF"/>
+                  <a:srgbClr val="CCCFD4"/>
                 </a:solidFill>
                 <a:latin typeface="Noto Sans KR"/>
                 <a:ea typeface="Noto Sans KR"/>
@@ -4210,7 +4210,7 @@
             <a:r>
               <a:rPr sz="2025" b="1">
                 <a:solidFill>
-                  <a:srgbClr val="16243D"/>
+                  <a:srgbClr val="193E51"/>
                 </a:solidFill>
                 <a:latin typeface="Noto Sans KR"/>
                 <a:ea typeface="Noto Sans KR"/>
@@ -4336,7 +4336,7 @@
             <a:r>
               <a:rPr sz="1800" b="1">
                 <a:solidFill>
-                  <a:srgbClr val="FFFFFF"/>
+                  <a:srgbClr val="B9BDC5"/>
                 </a:solidFill>
                 <a:latin typeface="Noto Sans KR"/>
                 <a:ea typeface="Noto Sans KR"/>
@@ -4418,7 +4418,7 @@
             <a:r>
               <a:rPr sz="2025" b="0">
                 <a:solidFill>
-                  <a:srgbClr val="FFFFFF"/>
+                  <a:srgbClr val="CCCFD4"/>
                 </a:solidFill>
                 <a:latin typeface="Noto Sans KR"/>
                 <a:ea typeface="Noto Sans KR"/>
@@ -4527,7 +4527,7 @@
             <a:r>
               <a:rPr sz="1650" b="0">
                 <a:solidFill>
-                  <a:srgbClr val="0F1A2E"/>
+                  <a:srgbClr val="767D89"/>
                 </a:solidFill>
                 <a:latin typeface="Noto Sans KR"/>
                 <a:ea typeface="Noto Sans KR"/>
@@ -4635,7 +4635,7 @@
             <a:r>
               <a:rPr sz="1800" b="0" spc="-18">
                 <a:solidFill>
-                  <a:srgbClr val="0F1A2E"/>
+                  <a:srgbClr val="7B818C"/>
                 </a:solidFill>
                 <a:latin typeface="Noto Sans KR"/>
                 <a:ea typeface="Noto Sans KR"/>
@@ -5280,7 +5280,7 @@
             <a:r>
               <a:rPr sz="1950" b="0">
                 <a:solidFill>
-                  <a:srgbClr val="16243D"/>
+                  <a:srgbClr val="1B4757"/>
                 </a:solidFill>
                 <a:latin typeface="Noto Sans KR"/>
                 <a:ea typeface="Noto Sans KR"/>
@@ -5598,7 +5598,7 @@
             <a:r>
               <a:rPr sz="1650" b="0">
                 <a:solidFill>
-                  <a:srgbClr val="0F1A2E"/>
+                  <a:srgbClr val="7B818C"/>
                 </a:solidFill>
                 <a:latin typeface="Noto Sans KR"/>
                 <a:ea typeface="Noto Sans KR"/>
@@ -5706,7 +5706,7 @@
             <a:r>
               <a:rPr sz="1800" b="0" spc="-18">
                 <a:solidFill>
-                  <a:srgbClr val="FFFFFF"/>
+                  <a:srgbClr val="969CA8"/>
                 </a:solidFill>
                 <a:latin typeface="Noto Sans KR"/>
                 <a:ea typeface="Noto Sans KR"/>
@@ -7285,7 +7285,7 @@
             <a:r>
               <a:rPr sz="1800" b="0" spc="-18">
                 <a:solidFill>
-                  <a:srgbClr val="0F1A2E"/>
+                  <a:srgbClr val="797E87"/>
                 </a:solidFill>
                 <a:latin typeface="Noto Sans KR"/>
                 <a:ea typeface="Noto Sans KR"/>

</xml_diff>